<commit_message>
Fill in team details: Alpha Devs
Replaces the [TEAM NAME] placeholder in all three places it appeared —
the deck generator, the report generator, and the AGPL copyright notice
in ATTRIBUTION.md section 6 — and rebuilds both documents.

Member names are set in title case rather than the capitals they were
supplied in, to match the deck's typography and the existing git
authorship.

No placeholders remain in the repository.

Co-Authored-By: Claude Opus 5 <noreply@anthropic.com>
</commit_message>
<xml_diff>
--- a/submission/Surat-Traffic-Intelligence-PS08.pptx
+++ b/submission/Surat-Traffic-Intelligence-PS08.pptx
@@ -3956,7 +3956,7 @@
                 </a:solidFill>
                 <a:latin typeface="Segoe UI"/>
               </a:rPr>
-              <a:t>[TEAM NAME]
+              <a:t>Alpha Devs
 </a:t>
             </a:r>
             <a:r>
@@ -3966,7 +3966,7 @@
                 </a:solidFill>
                 <a:latin typeface="Segoe UI"/>
               </a:rPr>
-              <a:t>[Member 1]  ·  [Member 2]  ·  [Member 3]  ·  [Member 4]</a:t>
+              <a:t>Rudraksh Fanse  ·  Rushang Bagada  ·  Ayushman Singh  ·  Nikhil Pathak</a:t>
             </a:r>
           </a:p>
         </p:txBody>

</xml_diff>